<commit_message>
after exam final push
</commit_message>
<xml_diff>
--- a/deliverables/presentation.pptx
+++ b/deliverables/presentation.pptx
@@ -13570,10 +13570,10 @@
         </p:nvGrpSpPr>
         <p:grpSpPr>
           <a:xfrm>
-            <a:off x="263598" y="1756901"/>
-            <a:ext cx="11855303" cy="4076623"/>
-            <a:chOff x="247649" y="1894631"/>
-            <a:chExt cx="11855303" cy="4076623"/>
+            <a:off x="162976" y="1755937"/>
+            <a:ext cx="12029024" cy="4076623"/>
+            <a:chOff x="147027" y="1893667"/>
+            <a:chExt cx="12029024" cy="4076623"/>
           </a:xfrm>
         </p:grpSpPr>
         <p:pic>
@@ -13605,7 +13605,7 @@
           </p:blipFill>
           <p:spPr>
             <a:xfrm>
-              <a:off x="6169928" y="1894631"/>
+              <a:off x="6243027" y="1893667"/>
               <a:ext cx="5933024" cy="4076623"/>
             </a:xfrm>
             <a:prstGeom prst="rect">
@@ -13642,7 +13642,7 @@
           </p:blipFill>
           <p:spPr>
             <a:xfrm>
-              <a:off x="247649" y="1894632"/>
+              <a:off x="147027" y="1893667"/>
               <a:ext cx="5933024" cy="3748374"/>
             </a:xfrm>
             <a:prstGeom prst="rect">
@@ -14018,6 +14018,48 @@
           </a:p>
         </p:txBody>
       </p:sp>
+      <p:cxnSp>
+        <p:nvCxnSpPr>
+          <p:cNvPr id="8" name="Connettore diritto 7">
+            <a:extLst>
+              <a:ext uri="{FF2B5EF4-FFF2-40B4-BE49-F238E27FC236}">
+                <a16:creationId xmlns:a16="http://schemas.microsoft.com/office/drawing/2014/main" id="{1D19631A-9FAC-D2F4-DE49-B3AD2AA39C6A}"/>
+              </a:ext>
+            </a:extLst>
+          </p:cNvPr>
+          <p:cNvCxnSpPr/>
+          <p:nvPr/>
+        </p:nvCxnSpPr>
+        <p:spPr>
+          <a:xfrm>
+            <a:off x="6108441" y="1912026"/>
+            <a:ext cx="0" cy="3592285"/>
+          </a:xfrm>
+          <a:prstGeom prst="line">
+            <a:avLst/>
+          </a:prstGeom>
+          <a:ln w="9525">
+            <a:solidFill>
+              <a:schemeClr val="tx1"/>
+            </a:solidFill>
+          </a:ln>
+          <a:effectLst/>
+        </p:spPr>
+        <p:style>
+          <a:lnRef idx="1">
+            <a:schemeClr val="accent1"/>
+          </a:lnRef>
+          <a:fillRef idx="0">
+            <a:schemeClr val="accent1"/>
+          </a:fillRef>
+          <a:effectRef idx="0">
+            <a:schemeClr val="accent1"/>
+          </a:effectRef>
+          <a:fontRef idx="minor">
+            <a:schemeClr val="tx1"/>
+          </a:fontRef>
+        </p:style>
+      </p:cxnSp>
     </p:spTree>
     <p:extLst>
       <p:ext uri="{BB962C8B-B14F-4D97-AF65-F5344CB8AC3E}">
@@ -14080,10 +14122,10 @@
         </p:nvGrpSpPr>
         <p:grpSpPr>
           <a:xfrm>
-            <a:off x="216958" y="1768327"/>
-            <a:ext cx="11928402" cy="4115151"/>
-            <a:chOff x="206448" y="2021951"/>
-            <a:chExt cx="11928402" cy="4115151"/>
+            <a:off x="123649" y="1768327"/>
+            <a:ext cx="12062128" cy="4115151"/>
+            <a:chOff x="187786" y="2021951"/>
+            <a:chExt cx="12062128" cy="4115151"/>
           </a:xfrm>
         </p:grpSpPr>
         <p:pic>
@@ -14115,7 +14157,7 @@
           </p:blipFill>
           <p:spPr>
             <a:xfrm>
-              <a:off x="206448" y="2021951"/>
+              <a:off x="187786" y="2021951"/>
               <a:ext cx="6051477" cy="3773393"/>
             </a:xfrm>
             <a:prstGeom prst="rect">
@@ -14145,15 +14187,15 @@
                 </a:ext>
               </a:extLst>
             </a:blip>
-            <a:srcRect l="12694" t="7658" r="6789" b="1731"/>
+            <a:srcRect l="12694" t="7658" r="7125" b="1731"/>
             <a:stretch>
               <a:fillRect/>
             </a:stretch>
           </p:blipFill>
           <p:spPr>
             <a:xfrm>
-              <a:off x="6162675" y="2093598"/>
-              <a:ext cx="5972175" cy="4043504"/>
+              <a:off x="6302639" y="2093598"/>
+              <a:ext cx="5947275" cy="4043504"/>
             </a:xfrm>
             <a:prstGeom prst="rect">
               <a:avLst/>
@@ -14528,6 +14570,48 @@
           </a:p>
         </p:txBody>
       </p:sp>
+      <p:cxnSp>
+        <p:nvCxnSpPr>
+          <p:cNvPr id="3" name="Connettore diritto 2">
+            <a:extLst>
+              <a:ext uri="{FF2B5EF4-FFF2-40B4-BE49-F238E27FC236}">
+                <a16:creationId xmlns:a16="http://schemas.microsoft.com/office/drawing/2014/main" id="{569E8FE9-96BF-2839-1FBF-2018F05DB1D4}"/>
+              </a:ext>
+            </a:extLst>
+          </p:cNvPr>
+          <p:cNvCxnSpPr/>
+          <p:nvPr/>
+        </p:nvCxnSpPr>
+        <p:spPr>
+          <a:xfrm>
+            <a:off x="6108441" y="1912026"/>
+            <a:ext cx="0" cy="3592285"/>
+          </a:xfrm>
+          <a:prstGeom prst="line">
+            <a:avLst/>
+          </a:prstGeom>
+          <a:ln w="9525">
+            <a:solidFill>
+              <a:schemeClr val="tx1"/>
+            </a:solidFill>
+          </a:ln>
+          <a:effectLst/>
+        </p:spPr>
+        <p:style>
+          <a:lnRef idx="1">
+            <a:schemeClr val="accent1"/>
+          </a:lnRef>
+          <a:fillRef idx="0">
+            <a:schemeClr val="accent1"/>
+          </a:fillRef>
+          <a:effectRef idx="0">
+            <a:schemeClr val="accent1"/>
+          </a:effectRef>
+          <a:fontRef idx="minor">
+            <a:schemeClr val="tx1"/>
+          </a:fontRef>
+        </p:style>
+      </p:cxnSp>
     </p:spTree>
     <p:extLst>
       <p:ext uri="{BB962C8B-B14F-4D97-AF65-F5344CB8AC3E}">

</xml_diff>